<commit_message>
Update META copy.pptx with latest revision
Co-Authored-By: Claude Sonnet 4.6 <noreply@anthropic.com>
</commit_message>
<xml_diff>
--- a/META copy.pptx
+++ b/META copy.pptx
@@ -261,7 +261,7 @@
           <a:p>
             <a:fld id="{AB7ED993-19DA-3F49-AFFD-C4F83A9F7DE0}" type="datetimeFigureOut">
               <a:rPr lang="en-IT" smtClean="0"/>
-              <a:t>02/05/26</a:t>
+              <a:t>05/05/26</a:t>
             </a:fld>
             <a:endParaRPr lang="en-IT"/>
           </a:p>
@@ -762,7 +762,7 @@
           <a:p>
             <a:fld id="{14B96D53-B5A5-CA41-931F-2C2D906BE50C}" type="datetimeFigureOut">
               <a:rPr lang="en-IT" smtClean="0"/>
-              <a:t>02/05/26</a:t>
+              <a:t>05/05/26</a:t>
             </a:fld>
             <a:endParaRPr lang="en-IT"/>
           </a:p>
@@ -962,7 +962,7 @@
           <a:p>
             <a:fld id="{14B96D53-B5A5-CA41-931F-2C2D906BE50C}" type="datetimeFigureOut">
               <a:rPr lang="en-IT" smtClean="0"/>
-              <a:t>02/05/26</a:t>
+              <a:t>05/05/26</a:t>
             </a:fld>
             <a:endParaRPr lang="en-IT"/>
           </a:p>
@@ -1172,7 +1172,7 @@
           <a:p>
             <a:fld id="{14B96D53-B5A5-CA41-931F-2C2D906BE50C}" type="datetimeFigureOut">
               <a:rPr lang="en-IT" smtClean="0"/>
-              <a:t>02/05/26</a:t>
+              <a:t>05/05/26</a:t>
             </a:fld>
             <a:endParaRPr lang="en-IT"/>
           </a:p>
@@ -1398,7 +1398,7 @@
           <a:p>
             <a:fld id="{C128FA71-3A18-48C0-980F-4B68F7F63042}" type="datetime1">
               <a:rPr lang="en-US" smtClean="0"/>
-              <a:t>5/2/26</a:t>
+              <a:t>5/5/26</a:t>
             </a:fld>
             <a:endParaRPr lang="en-US"/>
           </a:p>
@@ -1596,7 +1596,7 @@
           <a:p>
             <a:fld id="{51C1210E-201E-4473-82AC-2466F5386C38}" type="datetime1">
               <a:rPr lang="en-US" smtClean="0"/>
-              <a:t>5/2/26</a:t>
+              <a:t>5/5/26</a:t>
             </a:fld>
             <a:endParaRPr lang="en-US"/>
           </a:p>
@@ -1874,7 +1874,7 @@
           <a:p>
             <a:fld id="{B01EA198-6CAB-4B8F-B93F-1F9C8C4B6CE7}" type="datetime1">
               <a:rPr lang="en-US" smtClean="0"/>
-              <a:t>5/2/26</a:t>
+              <a:t>5/5/26</a:t>
             </a:fld>
             <a:endParaRPr lang="en-US"/>
           </a:p>
@@ -2146,7 +2146,7 @@
           <a:p>
             <a:fld id="{CA06041F-4525-44D5-AA4F-332294BF1F56}" type="datetime1">
               <a:rPr lang="en-US" smtClean="0"/>
-              <a:t>5/2/26</a:t>
+              <a:t>5/5/26</a:t>
             </a:fld>
             <a:endParaRPr lang="en-US"/>
           </a:p>
@@ -2570,7 +2570,7 @@
           <a:p>
             <a:fld id="{F9557091-BBDF-4EB9-BA6B-2BB67AC4FC0F}" type="datetime1">
               <a:rPr lang="en-US" smtClean="0"/>
-              <a:t>5/2/26</a:t>
+              <a:t>5/5/26</a:t>
             </a:fld>
             <a:endParaRPr lang="en-US"/>
           </a:p>
@@ -2711,7 +2711,7 @@
           <a:p>
             <a:fld id="{2D6B226B-77A6-410C-9796-083F278E0125}" type="datetime1">
               <a:rPr lang="en-US" smtClean="0"/>
-              <a:t>5/2/26</a:t>
+              <a:t>5/5/26</a:t>
             </a:fld>
             <a:endParaRPr lang="en-US"/>
           </a:p>
@@ -3030,7 +3030,7 @@
           <a:p>
             <a:fld id="{713DFAE3-14DB-48A7-A80F-80DDB072CE3D}" type="datetime1">
               <a:rPr lang="en-US" smtClean="0"/>
-              <a:t>5/2/26</a:t>
+              <a:t>5/5/26</a:t>
             </a:fld>
             <a:endParaRPr lang="en-US"/>
           </a:p>
@@ -3324,7 +3324,7 @@
           <a:p>
             <a:fld id="{92C5EAEF-6478-4102-8F5D-A5FE9FC97ACB}" type="datetime1">
               <a:rPr lang="en-US" smtClean="0"/>
-              <a:t>5/2/26</a:t>
+              <a:t>5/5/26</a:t>
             </a:fld>
             <a:endParaRPr lang="en-US"/>
           </a:p>
@@ -3524,7 +3524,7 @@
           <a:p>
             <a:fld id="{14B96D53-B5A5-CA41-931F-2C2D906BE50C}" type="datetimeFigureOut">
               <a:rPr lang="en-IT" smtClean="0"/>
-              <a:t>02/05/26</a:t>
+              <a:t>05/05/26</a:t>
             </a:fld>
             <a:endParaRPr lang="en-IT"/>
           </a:p>
@@ -3732,7 +3732,7 @@
           <a:p>
             <a:fld id="{7104EDB3-C0E8-45F8-9E1D-1B6C8D1880C0}" type="datetime1">
               <a:rPr lang="en-US" smtClean="0"/>
-              <a:t>5/2/26</a:t>
+              <a:t>5/5/26</a:t>
             </a:fld>
             <a:endParaRPr lang="en-US"/>
           </a:p>
@@ -3942,7 +3942,7 @@
           <a:p>
             <a:fld id="{9CF0EC4B-54ED-4041-B552-9BA760FA3DBA}" type="datetime1">
               <a:rPr lang="en-US" smtClean="0"/>
-              <a:t>5/2/26</a:t>
+              <a:t>5/5/26</a:t>
             </a:fld>
             <a:endParaRPr lang="en-US"/>
           </a:p>
@@ -4253,7 +4253,7 @@
           <a:p>
             <a:fld id="{14B96D53-B5A5-CA41-931F-2C2D906BE50C}" type="datetimeFigureOut">
               <a:rPr lang="en-IT" smtClean="0"/>
-              <a:t>02/05/26</a:t>
+              <a:t>05/05/26</a:t>
             </a:fld>
             <a:endParaRPr lang="en-IT"/>
           </a:p>
@@ -4521,7 +4521,7 @@
           <a:p>
             <a:fld id="{14B96D53-B5A5-CA41-931F-2C2D906BE50C}" type="datetimeFigureOut">
               <a:rPr lang="en-IT" smtClean="0"/>
-              <a:t>02/05/26</a:t>
+              <a:t>05/05/26</a:t>
             </a:fld>
             <a:endParaRPr lang="en-IT"/>
           </a:p>
@@ -4936,7 +4936,7 @@
           <a:p>
             <a:fld id="{14B96D53-B5A5-CA41-931F-2C2D906BE50C}" type="datetimeFigureOut">
               <a:rPr lang="en-IT" smtClean="0"/>
-              <a:t>02/05/26</a:t>
+              <a:t>05/05/26</a:t>
             </a:fld>
             <a:endParaRPr lang="en-IT"/>
           </a:p>
@@ -5078,7 +5078,7 @@
           <a:p>
             <a:fld id="{14B96D53-B5A5-CA41-931F-2C2D906BE50C}" type="datetimeFigureOut">
               <a:rPr lang="en-IT" smtClean="0"/>
-              <a:t>02/05/26</a:t>
+              <a:t>05/05/26</a:t>
             </a:fld>
             <a:endParaRPr lang="en-IT"/>
           </a:p>
@@ -5191,7 +5191,7 @@
           <a:p>
             <a:fld id="{14B96D53-B5A5-CA41-931F-2C2D906BE50C}" type="datetimeFigureOut">
               <a:rPr lang="en-IT" smtClean="0"/>
-              <a:t>02/05/26</a:t>
+              <a:t>05/05/26</a:t>
             </a:fld>
             <a:endParaRPr lang="en-IT"/>
           </a:p>
@@ -5504,7 +5504,7 @@
           <a:p>
             <a:fld id="{14B96D53-B5A5-CA41-931F-2C2D906BE50C}" type="datetimeFigureOut">
               <a:rPr lang="en-IT" smtClean="0"/>
-              <a:t>02/05/26</a:t>
+              <a:t>05/05/26</a:t>
             </a:fld>
             <a:endParaRPr lang="en-IT"/>
           </a:p>
@@ -5793,7 +5793,7 @@
           <a:p>
             <a:fld id="{14B96D53-B5A5-CA41-931F-2C2D906BE50C}" type="datetimeFigureOut">
               <a:rPr lang="en-IT" smtClean="0"/>
-              <a:t>02/05/26</a:t>
+              <a:t>05/05/26</a:t>
             </a:fld>
             <a:endParaRPr lang="en-IT"/>
           </a:p>
@@ -6036,7 +6036,7 @@
           <a:p>
             <a:fld id="{14B96D53-B5A5-CA41-931F-2C2D906BE50C}" type="datetimeFigureOut">
               <a:rPr lang="en-IT" smtClean="0"/>
-              <a:t>02/05/26</a:t>
+              <a:t>05/05/26</a:t>
             </a:fld>
             <a:endParaRPr lang="en-IT"/>
           </a:p>
@@ -6604,7 +6604,7 @@
           <a:p>
             <a:fld id="{67F45AC6-C491-4585-A584-9CE2AF7D5500}" type="datetime1">
               <a:rPr lang="en-US" smtClean="0"/>
-              <a:t>5/2/26</a:t>
+              <a:t>5/5/26</a:t>
             </a:fld>
             <a:endParaRPr lang="en-US"/>
           </a:p>
@@ -27767,7 +27767,7 @@
         </p:nvSpPr>
         <p:spPr>
           <a:xfrm>
-            <a:off x="8851391" y="914400"/>
+            <a:off x="8963207" y="914400"/>
             <a:ext cx="2241133" cy="4049038"/>
           </a:xfrm>
           <a:prstGeom prst="roundRect">
@@ -27956,7 +27956,7 @@
         </p:nvSpPr>
         <p:spPr>
           <a:xfrm>
-            <a:off x="9728480" y="4213849"/>
+            <a:off x="9827709" y="4227379"/>
             <a:ext cx="609462" cy="830997"/>
           </a:xfrm>
           <a:prstGeom prst="rect">
@@ -28250,7 +28250,7 @@
         </p:nvSpPr>
         <p:spPr>
           <a:xfrm>
-            <a:off x="8760377" y="1334348"/>
+            <a:off x="8872193" y="1348446"/>
             <a:ext cx="2423160" cy="685800"/>
           </a:xfrm>
           <a:prstGeom prst="rect">
@@ -28322,7 +28322,7 @@
         </p:nvSpPr>
         <p:spPr>
           <a:xfrm>
-            <a:off x="8963207" y="2212410"/>
+            <a:off x="9062436" y="2226088"/>
             <a:ext cx="2140008" cy="1828800"/>
           </a:xfrm>
           <a:prstGeom prst="rect">

</xml_diff>